<commit_message>
Arabic font hardening: Amiri in the latin slot for Arabic-only runs; add check-fonts.js
Some Arabic-only runs (pills, labels) still named Calibri in the latin slot; some editors shape Arabic with that slot
when the text box is clicked. Arabic-only runs now use Amiri in latin, ea and cs (mixed English/Arabic runs keep
Calibri for the English). check-fonts.js verifies every deck; all 496 decks pass. Guided-practice defaults added.

Co-Authored-By: Claude Opus 5.5 <noreply@anthropic.com>
Claude-Session: https://claude.ai/code/session_01QWUKnGV7MRCnE8883pixoX
</commit_message>
<xml_diff>
--- a/Final_Revision/Exam_Practice/FR-L01_Writing_Workshop_Daily_Life_Food_and_Health.pptx
+++ b/Final_Revision/Exam_Practice/FR-L01_Writing_Workshop_Daily_Life_Food_and_Health.pptx
@@ -3848,7 +3848,7 @@
                 <a:solidFill>
                   <a:srgbClr val="FFFFFF"/>
                 </a:solidFill>
-                <a:latin typeface="Calibri" pitchFamily="34" charset="0"/>
+                <a:latin typeface="Amiri" pitchFamily="2" charset="-78"/>
                 <a:ea typeface="Amiri" pitchFamily="2" charset="-78"/>
                 <a:cs typeface="Amiri" pitchFamily="2" charset="-78"/>
               </a:rPr>
@@ -3914,7 +3914,7 @@
                 <a:solidFill>
                   <a:srgbClr val="FFFFFF"/>
                 </a:solidFill>
-                <a:latin typeface="Calibri" pitchFamily="34" charset="0"/>
+                <a:latin typeface="Amiri" pitchFamily="2" charset="-78"/>
                 <a:ea typeface="Amiri" pitchFamily="2" charset="-78"/>
                 <a:cs typeface="Amiri" pitchFamily="2" charset="-78"/>
               </a:rPr>
@@ -3980,7 +3980,7 @@
                 <a:solidFill>
                   <a:srgbClr val="FFFFFF"/>
                 </a:solidFill>
-                <a:latin typeface="Calibri" pitchFamily="34" charset="0"/>
+                <a:latin typeface="Amiri" pitchFamily="2" charset="-78"/>
                 <a:ea typeface="Amiri" pitchFamily="2" charset="-78"/>
                 <a:cs typeface="Amiri" pitchFamily="2" charset="-78"/>
               </a:rPr>
@@ -4046,7 +4046,7 @@
                 <a:solidFill>
                   <a:srgbClr val="FFFFFF"/>
                 </a:solidFill>
-                <a:latin typeface="Calibri" pitchFamily="34" charset="0"/>
+                <a:latin typeface="Amiri" pitchFamily="2" charset="-78"/>
                 <a:ea typeface="Amiri" pitchFamily="2" charset="-78"/>
                 <a:cs typeface="Amiri" pitchFamily="2" charset="-78"/>
               </a:rPr>
@@ -4844,7 +4844,7 @@
                 <a:solidFill>
                   <a:srgbClr val="FFFFFF"/>
                 </a:solidFill>
-                <a:latin typeface="Calibri" pitchFamily="34" charset="0"/>
+                <a:latin typeface="Amiri" pitchFamily="2" charset="-78"/>
                 <a:ea typeface="Amiri" pitchFamily="2" charset="-78"/>
                 <a:cs typeface="Amiri" pitchFamily="2" charset="-78"/>
               </a:rPr>
@@ -4910,7 +4910,7 @@
                 <a:solidFill>
                   <a:srgbClr val="FFFFFF"/>
                 </a:solidFill>
-                <a:latin typeface="Calibri" pitchFamily="34" charset="0"/>
+                <a:latin typeface="Amiri" pitchFamily="2" charset="-78"/>
                 <a:ea typeface="Amiri" pitchFamily="2" charset="-78"/>
                 <a:cs typeface="Amiri" pitchFamily="2" charset="-78"/>
               </a:rPr>
@@ -4976,7 +4976,7 @@
                 <a:solidFill>
                   <a:srgbClr val="FFFFFF"/>
                 </a:solidFill>
-                <a:latin typeface="Calibri" pitchFamily="34" charset="0"/>
+                <a:latin typeface="Amiri" pitchFamily="2" charset="-78"/>
                 <a:ea typeface="Amiri" pitchFamily="2" charset="-78"/>
                 <a:cs typeface="Amiri" pitchFamily="2" charset="-78"/>
               </a:rPr>
@@ -5042,7 +5042,7 @@
                 <a:solidFill>
                   <a:srgbClr val="FFFFFF"/>
                 </a:solidFill>
-                <a:latin typeface="Calibri" pitchFamily="34" charset="0"/>
+                <a:latin typeface="Amiri" pitchFamily="2" charset="-78"/>
                 <a:ea typeface="Amiri" pitchFamily="2" charset="-78"/>
                 <a:cs typeface="Amiri" pitchFamily="2" charset="-78"/>
               </a:rPr>
@@ -8599,7 +8599,7 @@
                 <a:solidFill>
                   <a:srgbClr val="FFFFFF"/>
                 </a:solidFill>
-                <a:latin typeface="Calibri" pitchFamily="34" charset="0"/>
+                <a:latin typeface="Amiri" pitchFamily="2" charset="-78"/>
                 <a:ea typeface="Amiri" pitchFamily="2" charset="-78"/>
                 <a:cs typeface="Amiri" pitchFamily="2" charset="-78"/>
               </a:rPr>
@@ -8665,7 +8665,7 @@
                 <a:solidFill>
                   <a:srgbClr val="FFFFFF"/>
                 </a:solidFill>
-                <a:latin typeface="Calibri" pitchFamily="34" charset="0"/>
+                <a:latin typeface="Amiri" pitchFamily="2" charset="-78"/>
                 <a:ea typeface="Amiri" pitchFamily="2" charset="-78"/>
                 <a:cs typeface="Amiri" pitchFamily="2" charset="-78"/>
               </a:rPr>
@@ -8731,7 +8731,7 @@
                 <a:solidFill>
                   <a:srgbClr val="FFFFFF"/>
                 </a:solidFill>
-                <a:latin typeface="Calibri" pitchFamily="34" charset="0"/>
+                <a:latin typeface="Amiri" pitchFamily="2" charset="-78"/>
                 <a:ea typeface="Amiri" pitchFamily="2" charset="-78"/>
                 <a:cs typeface="Amiri" pitchFamily="2" charset="-78"/>
               </a:rPr>
@@ -8797,7 +8797,7 @@
                 <a:solidFill>
                   <a:srgbClr val="FFFFFF"/>
                 </a:solidFill>
-                <a:latin typeface="Calibri" pitchFamily="34" charset="0"/>
+                <a:latin typeface="Amiri" pitchFamily="2" charset="-78"/>
                 <a:ea typeface="Amiri" pitchFamily="2" charset="-78"/>
                 <a:cs typeface="Amiri" pitchFamily="2" charset="-78"/>
               </a:rPr>
@@ -9584,7 +9584,7 @@
                 <a:solidFill>
                   <a:srgbClr val="FFFFFF"/>
                 </a:solidFill>
-                <a:latin typeface="Calibri" pitchFamily="34" charset="0"/>
+                <a:latin typeface="Amiri" pitchFamily="2" charset="-78"/>
                 <a:ea typeface="Amiri" pitchFamily="2" charset="-78"/>
                 <a:cs typeface="Amiri" pitchFamily="2" charset="-78"/>
               </a:rPr>
@@ -9650,7 +9650,7 @@
                 <a:solidFill>
                   <a:srgbClr val="FFFFFF"/>
                 </a:solidFill>
-                <a:latin typeface="Calibri" pitchFamily="34" charset="0"/>
+                <a:latin typeface="Amiri" pitchFamily="2" charset="-78"/>
                 <a:ea typeface="Amiri" pitchFamily="2" charset="-78"/>
                 <a:cs typeface="Amiri" pitchFamily="2" charset="-78"/>
               </a:rPr>
@@ -9716,7 +9716,7 @@
                 <a:solidFill>
                   <a:srgbClr val="FFFFFF"/>
                 </a:solidFill>
-                <a:latin typeface="Calibri" pitchFamily="34" charset="0"/>
+                <a:latin typeface="Amiri" pitchFamily="2" charset="-78"/>
                 <a:ea typeface="Amiri" pitchFamily="2" charset="-78"/>
                 <a:cs typeface="Amiri" pitchFamily="2" charset="-78"/>
               </a:rPr>
@@ -9782,7 +9782,7 @@
                 <a:solidFill>
                   <a:srgbClr val="FFFFFF"/>
                 </a:solidFill>
-                <a:latin typeface="Calibri" pitchFamily="34" charset="0"/>
+                <a:latin typeface="Amiri" pitchFamily="2" charset="-78"/>
                 <a:ea typeface="Amiri" pitchFamily="2" charset="-78"/>
                 <a:cs typeface="Amiri" pitchFamily="2" charset="-78"/>
               </a:rPr>
@@ -10569,7 +10569,7 @@
                 <a:solidFill>
                   <a:srgbClr val="FFFFFF"/>
                 </a:solidFill>
-                <a:latin typeface="Calibri" pitchFamily="34" charset="0"/>
+                <a:latin typeface="Amiri" pitchFamily="2" charset="-78"/>
                 <a:ea typeface="Amiri" pitchFamily="2" charset="-78"/>
                 <a:cs typeface="Amiri" pitchFamily="2" charset="-78"/>
               </a:rPr>
@@ -10635,7 +10635,7 @@
                 <a:solidFill>
                   <a:srgbClr val="FFFFFF"/>
                 </a:solidFill>
-                <a:latin typeface="Calibri" pitchFamily="34" charset="0"/>
+                <a:latin typeface="Amiri" pitchFamily="2" charset="-78"/>
                 <a:ea typeface="Amiri" pitchFamily="2" charset="-78"/>
                 <a:cs typeface="Amiri" pitchFamily="2" charset="-78"/>
               </a:rPr>
@@ -10701,7 +10701,7 @@
                 <a:solidFill>
                   <a:srgbClr val="FFFFFF"/>
                 </a:solidFill>
-                <a:latin typeface="Calibri" pitchFamily="34" charset="0"/>
+                <a:latin typeface="Amiri" pitchFamily="2" charset="-78"/>
                 <a:ea typeface="Amiri" pitchFamily="2" charset="-78"/>
                 <a:cs typeface="Amiri" pitchFamily="2" charset="-78"/>
               </a:rPr>
@@ -10767,7 +10767,7 @@
                 <a:solidFill>
                   <a:srgbClr val="FFFFFF"/>
                 </a:solidFill>
-                <a:latin typeface="Calibri" pitchFamily="34" charset="0"/>
+                <a:latin typeface="Amiri" pitchFamily="2" charset="-78"/>
                 <a:ea typeface="Amiri" pitchFamily="2" charset="-78"/>
                 <a:cs typeface="Amiri" pitchFamily="2" charset="-78"/>
               </a:rPr>

</xml_diff>